<commit_message>
docs: precisa en el informe y la presentación que los commits y ramas se cuentan hasta la etiqueta v0.4.0
</commit_message>
<xml_diff>
--- a/docs/entregables/APF3/APF3_VetSaludERP_Sustentacion.pptx
+++ b/docs/entregables/APF3/APF3_VetSaludERP_Sustentacion.pptx
@@ -120,13 +120,13 @@
   <p:extLst>
     <p:ext uri="{521415D9-36F7-43E2-AB2F-B90AF26B5E84}">
       <p14:sectionLst xmlns:p14="http://schemas.microsoft.com/office/powerpoint/2010/main">
-        <p14:section name="Introducción" id="{b087c98d-6a20-af18-a0c7-011c36b680cc}">
+        <p14:section name="Introducción" id="{bcba5ae5-e8ab-cf10-3af9-2fd61c65d17e}">
           <p14:sldIdLst>
             <p14:sldId id="256"/>
             <p14:sldId id="257"/>
           </p14:sldIdLst>
         </p14:section>
-        <p14:section name="Diseño" id="{6d93afd5-f4ac-78c1-c074-c37e330608f1}">
+        <p14:section name="Diseño" id="{60d8652f-1b76-8e5f-2787-97e00ff68d61}">
           <p14:sldIdLst>
             <p14:sldId id="258"/>
             <p14:sldId id="259"/>
@@ -134,7 +134,7 @@
             <p14:sldId id="261"/>
           </p14:sldIdLst>
         </p14:section>
-        <p14:section name="Construcción" id="{6691c31f-febb-84d0-ce15-719795d41f7a}">
+        <p14:section name="Construcción" id="{2df4b63e-13e5-b428-fcdf-fa55ce329424}">
           <p14:sldIdLst>
             <p14:sldId id="262"/>
             <p14:sldId id="263"/>
@@ -144,7 +144,7 @@
             <p14:sldId id="267"/>
           </p14:sldIdLst>
         </p14:section>
-        <p14:section name="Resultados" id="{59547e31-e9f5-29a3-15f4-e1215bb79ea1}">
+        <p14:section name="Resultados" id="{5a030a8b-bbb1-ce2a-c661-d4b562d15efb}">
           <p14:sldIdLst>
             <p14:sldId id="268"/>
             <p14:sldId id="269"/>
@@ -8259,7 +8259,7 @@
                   <a:schemeClr val="tx1"/>
                 </a:solidFill>
               </a:rPr>
-              <a:t>commits con convención tipo: verbo (RF-xx)</a:t>
+              <a:t>commits en la versión v0.4.0 · convención tipo: verbo (RF-xx)</a:t>
             </a:r>
             <a:endParaRPr lang="en-US" sz="1200" dirty="0"/>
           </a:p>
@@ -8334,7 +8334,7 @@
                   <a:schemeClr val="tx1"/>
                 </a:solidFill>
               </a:rPr>
-              <a:t>ramas de funcionalidad integradas con merge --no-ff</a:t>
+              <a:t>ramas integradas con merge --no-ff hasta v0.4.0</a:t>
             </a:r>
             <a:endParaRPr lang="en-US" sz="1200" dirty="0"/>
           </a:p>

</xml_diff>